<commit_message>
Replace HKM branding with AMO
Co-authored-by: Copilot <223556219+Copilot@users.noreply.github.com>
</commit_message>
<xml_diff>
--- a/examples/Exterior design evaluation – Mercedes GLS.pptx
+++ b/examples/Exterior design evaluation – Mercedes GLS.pptx
@@ -3206,7 +3206,7 @@
                 <a:ea typeface="+mn-ea"/>
                 <a:cs typeface="+mn-cs"/>
               </a:rPr>
-              <a:t>Source: HKM Survey, Base: n=203</a:t>
+              <a:t>Source: AMO Survey, Base: n=203</a:t>
             </a:r>
           </a:p>
           <a:p>
@@ -3814,7 +3814,7 @@
 <file path=ppt/theme/theme1.xml><?xml version="1.0" encoding="utf-8"?>
 <a:theme xmlns:a="http://schemas.openxmlformats.org/drawingml/2006/main" name="1_Chapter Slides">
   <a:themeElements>
-    <a:clrScheme name="HKM3">
+    <a:clrScheme name="AMO3">
       <a:dk1>
         <a:srgbClr val="595959"/>
       </a:dk1>
@@ -3852,7 +3852,7 @@
         <a:srgbClr val="BD357C"/>
       </a:folHlink>
     </a:clrScheme>
-    <a:fontScheme name="HKM1">
+    <a:fontScheme name="AMO1">
       <a:majorFont>
         <a:latin typeface="Tw Cen MT"/>
         <a:ea typeface=""/>

</xml_diff>